<commit_message>
business: deck actualizado con siluetas de campaña y exportación PDF
- Slide 15: imagen de marca con par femenino y masculino en perfil lateral,
  arcos azul/verde en colores de la identidad visual (Care · Connection ·
  Clarity · Confidence)
- Generado PDF del pitch deck completo (15 slides)

Co-Authored-By: Claude Sonnet 4.6 <noreply@anthropic.com>
</commit_message>
<xml_diff>
--- a/business/CareSignal_Pitch_Deck_publico.pptx
+++ b/business/CareSignal_Pitch_Deck_publico.pptx
@@ -5,7 +5,7 @@
     <p:sldMasterId id="2147483648" r:id="rId1"/>
   </p:sldMasterIdLst>
   <p:notesMasterIdLst>
-    <p:notesMasterId r:id="rId16"/>
+    <p:notesMasterId r:id="rId17"/>
   </p:notesMasterIdLst>
   <p:sldIdLst>
     <p:sldId id="256" r:id="rId2"/>
@@ -22,6 +22,7 @@
     <p:sldId id="267" r:id="rId13"/>
     <p:sldId id="268" r:id="rId14"/>
     <p:sldId id="269" r:id="rId15"/>
+    <p:sldId id="270" r:id="rId16"/>
   </p:sldIdLst>
   <p:sldSz cx="12192000" cy="6858000"/>
   <p:notesSz cx="6858000" cy="12192000"/>
@@ -4706,7 +4707,51 @@
                 <a:ea typeface="Arial" pitchFamily="34" charset="-122"/>
                 <a:cs typeface="Arial" pitchFamily="34" charset="-120"/>
               </a:rPr>
-              <a:t>⚠️ Precios de referencia — no validados con clientes reales. El tier Freemium opera sin SLA ni </a:t>
+              <a:t>⚠️ Precios de </a:t>
+            </a:r>
+            <a:r>
+              <a:rPr lang="en-US" dirty="0" err="1">
+                <a:solidFill>
+                  <a:srgbClr val="718096"/>
+                </a:solidFill>
+                <a:latin typeface="Arial" pitchFamily="34" charset="0"/>
+                <a:ea typeface="Arial" pitchFamily="34" charset="-122"/>
+                <a:cs typeface="Arial" pitchFamily="34" charset="-120"/>
+              </a:rPr>
+              <a:t>referencia</a:t>
+            </a:r>
+            <a:r>
+              <a:rPr lang="en-US" dirty="0">
+                <a:solidFill>
+                  <a:srgbClr val="718096"/>
+                </a:solidFill>
+                <a:latin typeface="Arial" pitchFamily="34" charset="0"/>
+                <a:ea typeface="Arial" pitchFamily="34" charset="-122"/>
+                <a:cs typeface="Arial" pitchFamily="34" charset="-120"/>
+              </a:rPr>
+              <a:t> </a:t>
+            </a:r>
+            <a:r>
+              <a:rPr lang="en-US" dirty="0" err="1">
+                <a:solidFill>
+                  <a:srgbClr val="718096"/>
+                </a:solidFill>
+                <a:latin typeface="Arial" pitchFamily="34" charset="0"/>
+                <a:ea typeface="Arial" pitchFamily="34" charset="-122"/>
+                <a:cs typeface="Arial" pitchFamily="34" charset="-120"/>
+              </a:rPr>
+              <a:t>estimados</a:t>
+            </a:r>
+            <a:r>
+              <a:rPr lang="en-US" dirty="0">
+                <a:solidFill>
+                  <a:srgbClr val="718096"/>
+                </a:solidFill>
+                <a:latin typeface="Arial" pitchFamily="34" charset="0"/>
+                <a:ea typeface="Arial" pitchFamily="34" charset="-122"/>
+                <a:cs typeface="Arial" pitchFamily="34" charset="-120"/>
+              </a:rPr>
+              <a:t>. El tier Freemium opera sin SLA ni </a:t>
             </a:r>
             <a:r>
               <a:rPr lang="en-US" dirty="0" err="1">
@@ -9338,6 +9383,66 @@
 </p:sld>
 </file>
 
+<file path=ppt/slides/slide15.xml><?xml version="1.0" encoding="utf-8"?>
+<p:sld xmlns:a="http://schemas.openxmlformats.org/drawingml/2006/main" xmlns:r="http://schemas.openxmlformats.org/officeDocument/2006/relationships" xmlns:p="http://schemas.openxmlformats.org/presentationml/2006/main">
+  <p:cSld>
+    <p:spTree>
+      <p:nvGrpSpPr>
+        <p:cNvPr id="1" name=""/>
+        <p:cNvGrpSpPr/>
+        <p:nvPr/>
+      </p:nvGrpSpPr>
+      <p:grpSpPr>
+        <a:xfrm>
+          <a:off x="0" y="0"/>
+          <a:ext cx="0" cy="0"/>
+          <a:chOff x="0" y="0"/>
+          <a:chExt cx="0" cy="0"/>
+        </a:xfrm>
+      </p:grpSpPr>
+      <p:pic>
+        <p:nvPicPr>
+          <p:cNvPr id="3" name="Picture 2">
+            <a:extLst>
+              <a:ext uri="{FF2B5EF4-FFF2-40B4-BE49-F238E27FC236}">
+                <a16:creationId xmlns:a16="http://schemas.microsoft.com/office/drawing/2014/main" id="{8281D5C9-2FBA-D940-D54E-116A06E7BAFB}"/>
+              </a:ext>
+            </a:extLst>
+          </p:cNvPr>
+          <p:cNvPicPr>
+            <a:picLocks/>
+          </p:cNvPicPr>
+          <p:nvPr/>
+        </p:nvPicPr>
+        <p:blipFill>
+          <a:blip r:embed="rId2"/>
+          <a:stretch>
+            <a:fillRect/>
+          </a:stretch>
+        </p:blipFill>
+        <p:spPr>
+          <a:xfrm>
+            <a:off x="0" y="0"/>
+            <a:ext cx="12192000" cy="6858000"/>
+          </a:xfrm>
+          <a:prstGeom prst="rect">
+            <a:avLst/>
+          </a:prstGeom>
+        </p:spPr>
+      </p:pic>
+    </p:spTree>
+    <p:extLst>
+      <p:ext uri="{BB962C8B-B14F-4D97-AF65-F5344CB8AC3E}">
+        <p14:creationId xmlns:p14="http://schemas.microsoft.com/office/powerpoint/2010/main" val="566900812"/>
+      </p:ext>
+    </p:extLst>
+  </p:cSld>
+  <p:clrMapOvr>
+    <a:masterClrMapping/>
+  </p:clrMapOvr>
+</p:sld>
+</file>
+
 <file path=ppt/slides/slide2.xml><?xml version="1.0" encoding="utf-8"?>
 <p:sld xmlns:a="http://schemas.openxmlformats.org/drawingml/2006/main" xmlns:r="http://schemas.openxmlformats.org/officeDocument/2006/relationships" xmlns:p="http://schemas.openxmlformats.org/presentationml/2006/main">
   <p:cSld name="Slide 2">
@@ -13025,7 +13130,18 @@
                 <a:ea typeface="Arial" pitchFamily="34" charset="-122"/>
                 <a:cs typeface="Arial" pitchFamily="34" charset="-120"/>
               </a:rPr>
-              <a:t> administrativo</a:t>
+              <a:t> </a:t>
+            </a:r>
+            <a:r>
+              <a:rPr lang="en-US" b="1" dirty="0" err="1">
+                <a:solidFill>
+                  <a:srgbClr val="2D3748"/>
+                </a:solidFill>
+                <a:latin typeface="Arial" pitchFamily="34" charset="0"/>
+                <a:ea typeface="Arial" pitchFamily="34" charset="-122"/>
+                <a:cs typeface="Arial" pitchFamily="34" charset="-120"/>
+              </a:rPr>
+              <a:t>administrativa</a:t>
             </a:r>
             <a:endParaRPr lang="en-US" dirty="0"/>
           </a:p>
@@ -16750,6 +16866,73 @@
               <a:t>estimados</a:t>
             </a:r>
             <a:endParaRPr lang="en-US" dirty="0"/>
+          </a:p>
+        </p:txBody>
+      </p:sp>
+      <p:sp>
+        <p:nvSpPr>
+          <p:cNvPr id="27" name="Text 19">
+            <a:extLst>
+              <a:ext uri="{FF2B5EF4-FFF2-40B4-BE49-F238E27FC236}">
+                <a16:creationId xmlns:a16="http://schemas.microsoft.com/office/drawing/2014/main" id="{8B4D2336-CBB1-1250-7067-597B4E54D39E}"/>
+              </a:ext>
+            </a:extLst>
+          </p:cNvPr>
+          <p:cNvSpPr/>
+          <p:nvPr/>
+        </p:nvSpPr>
+        <p:spPr>
+          <a:xfrm>
+            <a:off x="6315456" y="4127353"/>
+            <a:ext cx="1694688" cy="316631"/>
+          </a:xfrm>
+          <a:prstGeom prst="rect">
+            <a:avLst/>
+          </a:prstGeom>
+          <a:noFill/>
+          <a:ln/>
+        </p:spPr>
+        <p:txBody>
+          <a:bodyPr wrap="square" rtlCol="0" anchor="ctr"/>
+          <a:lstStyle/>
+          <a:p>
+            <a:pPr marL="0" indent="0">
+              <a:buNone/>
+            </a:pPr>
+            <a:r>
+              <a:rPr lang="en-US" sz="1100" dirty="0">
+                <a:solidFill>
+                  <a:srgbClr val="2D3748"/>
+                </a:solidFill>
+                <a:latin typeface="Arial" pitchFamily="34" charset="0"/>
+                <a:ea typeface="Arial" pitchFamily="34" charset="-122"/>
+                <a:cs typeface="Arial" pitchFamily="34" charset="-120"/>
+              </a:rPr>
+              <a:t>*tier </a:t>
+            </a:r>
+            <a:r>
+              <a:rPr lang="en-US" sz="1100" dirty="0" err="1">
+                <a:solidFill>
+                  <a:srgbClr val="2D3748"/>
+                </a:solidFill>
+                <a:latin typeface="Arial" pitchFamily="34" charset="0"/>
+                <a:ea typeface="Arial" pitchFamily="34" charset="-122"/>
+                <a:cs typeface="Arial" pitchFamily="34" charset="-120"/>
+              </a:rPr>
+              <a:t>esencial</a:t>
+            </a:r>
+            <a:r>
+              <a:rPr lang="en-US" sz="1100" dirty="0">
+                <a:solidFill>
+                  <a:srgbClr val="2D3748"/>
+                </a:solidFill>
+                <a:latin typeface="Arial" pitchFamily="34" charset="0"/>
+                <a:ea typeface="Arial" pitchFamily="34" charset="-122"/>
+                <a:cs typeface="Arial" pitchFamily="34" charset="-120"/>
+              </a:rPr>
+              <a:t> ($3,500)</a:t>
+            </a:r>
+            <a:endParaRPr lang="en-US" sz="1100" dirty="0"/>
           </a:p>
         </p:txBody>
       </p:sp>

</xml_diff>

<commit_message>
business: imagen de campaña CareSignal y slide 15 del deck actualizada
Reemplaza el screenshot generado por la imagen final de diseño
(CareSignal.png) con los perfiles de abrazo y arcos de marca.

Co-Authored-By: Claude Sonnet 4.6 <noreply@anthropic.com>
</commit_message>
<xml_diff>
--- a/business/CareSignal_Pitch_Deck_publico.pptx
+++ b/business/CareSignal_Pitch_Deck_publico.pptx
@@ -9405,7 +9405,7 @@
           <p:cNvPr id="3" name="Picture 2">
             <a:extLst>
               <a:ext uri="{FF2B5EF4-FFF2-40B4-BE49-F238E27FC236}">
-                <a16:creationId xmlns:a16="http://schemas.microsoft.com/office/drawing/2014/main" id="{8281D5C9-2FBA-D940-D54E-116A06E7BAFB}"/>
+                <a16:creationId xmlns:a16="http://schemas.microsoft.com/office/drawing/2014/main" id="{4B5ACD39-2BF5-DFB7-C8D4-F8674BD1B204}"/>
               </a:ext>
             </a:extLst>
           </p:cNvPr>
@@ -9433,7 +9433,7 @@
     </p:spTree>
     <p:extLst>
       <p:ext uri="{BB962C8B-B14F-4D97-AF65-F5344CB8AC3E}">
-        <p14:creationId xmlns:p14="http://schemas.microsoft.com/office/powerpoint/2010/main" val="566900812"/>
+        <p14:creationId xmlns:p14="http://schemas.microsoft.com/office/powerpoint/2010/main" val="937068611"/>
       </p:ext>
     </p:extLst>
   </p:cSld>

</xml_diff>

<commit_message>
business + research: deck v2 y carpeta de investigación de mercado
- business/: versión 2 del pitch deck (pptx + pdf)
- research/: 25 documentos de análisis — tesis de inversión, modelo de
  negocio, PESTEL/FODA, datos de mercado México, perfiles de facility,
  datos EDA/ETL, riesgo operacional y expansión longitudinal

Co-Authored-By: Claude Sonnet 4.6 <noreply@anthropic.com>
</commit_message>
<xml_diff>
--- a/business/CareSignal_Pitch_Deck_publico.pptx
+++ b/business/CareSignal_Pitch_Deck_publico.pptx
@@ -5,7 +5,7 @@
     <p:sldMasterId id="2147483648" r:id="rId1"/>
   </p:sldMasterIdLst>
   <p:notesMasterIdLst>
-    <p:notesMasterId r:id="rId17"/>
+    <p:notesMasterId r:id="rId16"/>
   </p:notesMasterIdLst>
   <p:sldIdLst>
     <p:sldId id="256" r:id="rId2"/>
@@ -22,7 +22,6 @@
     <p:sldId id="267" r:id="rId13"/>
     <p:sldId id="268" r:id="rId14"/>
     <p:sldId id="269" r:id="rId15"/>
-    <p:sldId id="270" r:id="rId16"/>
   </p:sldIdLst>
   <p:sldSz cx="12192000" cy="6858000"/>
   <p:notesSz cx="6858000" cy="12192000"/>
@@ -1962,42 +1961,6 @@
       </p:sp>
       <p:sp>
         <p:nvSpPr>
-          <p:cNvPr id="8" name="Text 6"/>
-          <p:cNvSpPr/>
-          <p:nvPr/>
-        </p:nvSpPr>
-        <p:spPr>
-          <a:xfrm>
-            <a:off x="457200" y="822960"/>
-            <a:ext cx="914400" cy="914400"/>
-          </a:xfrm>
-          <a:prstGeom prst="rect">
-            <a:avLst/>
-          </a:prstGeom>
-          <a:noFill/>
-          <a:ln/>
-        </p:spPr>
-        <p:txBody>
-          <a:bodyPr wrap="square" rtlCol="0" anchor="ctr"/>
-          <a:lstStyle/>
-          <a:p>
-            <a:pPr marL="0" indent="0" algn="ctr">
-              <a:buNone/>
-            </a:pPr>
-            <a:r>
-              <a:rPr lang="en-US" sz="4800" dirty="0">
-                <a:solidFill>
-                  <a:srgbClr val="000000"/>
-                </a:solidFill>
-              </a:rPr>
-              <a:t>🛡️</a:t>
-            </a:r>
-            <a:endParaRPr lang="en-US" sz="4800" dirty="0"/>
-          </a:p>
-        </p:txBody>
-      </p:sp>
-      <p:sp>
-        <p:nvSpPr>
           <p:cNvPr id="9" name="Text 7"/>
           <p:cNvSpPr/>
           <p:nvPr/>
@@ -2644,6 +2607,67 @@
           </a:p>
         </p:txBody>
       </p:sp>
+      <p:pic>
+        <p:nvPicPr>
+          <p:cNvPr id="24" name="Picture 23">
+            <a:extLst>
+              <a:ext uri="{FF2B5EF4-FFF2-40B4-BE49-F238E27FC236}">
+                <a16:creationId xmlns:a16="http://schemas.microsoft.com/office/drawing/2014/main" id="{D115B6CE-726D-9CDE-30B4-0C548E20BB8E}"/>
+              </a:ext>
+            </a:extLst>
+          </p:cNvPr>
+          <p:cNvPicPr>
+            <a:picLocks/>
+          </p:cNvPicPr>
+          <p:nvPr/>
+        </p:nvPicPr>
+        <p:blipFill>
+          <a:blip r:embed="rId3"/>
+          <a:stretch>
+            <a:fillRect/>
+          </a:stretch>
+        </p:blipFill>
+        <p:spPr>
+          <a:xfrm>
+            <a:off x="9015984" y="201400"/>
+            <a:ext cx="3123642" cy="1993159"/>
+          </a:xfrm>
+          <a:prstGeom prst="rect">
+            <a:avLst/>
+          </a:prstGeom>
+        </p:spPr>
+      </p:pic>
+      <p:pic>
+        <p:nvPicPr>
+          <p:cNvPr id="26" name="Picture 25">
+            <a:extLst>
+              <a:ext uri="{FF2B5EF4-FFF2-40B4-BE49-F238E27FC236}">
+                <a16:creationId xmlns:a16="http://schemas.microsoft.com/office/drawing/2014/main" id="{96C188EA-BBA2-902A-C0B1-1BE336EBC6C3}"/>
+              </a:ext>
+            </a:extLst>
+          </p:cNvPr>
+          <p:cNvPicPr>
+            <a:picLocks/>
+          </p:cNvPicPr>
+          <p:nvPr/>
+        </p:nvPicPr>
+        <p:blipFill>
+          <a:blip r:embed="rId3"/>
+          <a:srcRect t="85135"/>
+          <a:stretch>
+            <a:fillRect/>
+          </a:stretch>
+        </p:blipFill>
+        <p:spPr>
+          <a:xfrm>
+            <a:off x="457200" y="5212080"/>
+            <a:ext cx="8971480" cy="822960"/>
+          </a:xfrm>
+          <a:prstGeom prst="rect">
+            <a:avLst/>
+          </a:prstGeom>
+        </p:spPr>
+      </p:pic>
     </p:spTree>
   </p:cSld>
   <p:clrMapOvr>
@@ -9376,66 +9400,6 @@
         </p:txBody>
       </p:sp>
     </p:spTree>
-  </p:cSld>
-  <p:clrMapOvr>
-    <a:masterClrMapping/>
-  </p:clrMapOvr>
-</p:sld>
-</file>
-
-<file path=ppt/slides/slide15.xml><?xml version="1.0" encoding="utf-8"?>
-<p:sld xmlns:a="http://schemas.openxmlformats.org/drawingml/2006/main" xmlns:r="http://schemas.openxmlformats.org/officeDocument/2006/relationships" xmlns:p="http://schemas.openxmlformats.org/presentationml/2006/main">
-  <p:cSld>
-    <p:spTree>
-      <p:nvGrpSpPr>
-        <p:cNvPr id="1" name=""/>
-        <p:cNvGrpSpPr/>
-        <p:nvPr/>
-      </p:nvGrpSpPr>
-      <p:grpSpPr>
-        <a:xfrm>
-          <a:off x="0" y="0"/>
-          <a:ext cx="0" cy="0"/>
-          <a:chOff x="0" y="0"/>
-          <a:chExt cx="0" cy="0"/>
-        </a:xfrm>
-      </p:grpSpPr>
-      <p:pic>
-        <p:nvPicPr>
-          <p:cNvPr id="3" name="Picture 2">
-            <a:extLst>
-              <a:ext uri="{FF2B5EF4-FFF2-40B4-BE49-F238E27FC236}">
-                <a16:creationId xmlns:a16="http://schemas.microsoft.com/office/drawing/2014/main" id="{4B5ACD39-2BF5-DFB7-C8D4-F8674BD1B204}"/>
-              </a:ext>
-            </a:extLst>
-          </p:cNvPr>
-          <p:cNvPicPr>
-            <a:picLocks/>
-          </p:cNvPicPr>
-          <p:nvPr/>
-        </p:nvPicPr>
-        <p:blipFill>
-          <a:blip r:embed="rId2"/>
-          <a:stretch>
-            <a:fillRect/>
-          </a:stretch>
-        </p:blipFill>
-        <p:spPr>
-          <a:xfrm>
-            <a:off x="0" y="0"/>
-            <a:ext cx="12192000" cy="6858000"/>
-          </a:xfrm>
-          <a:prstGeom prst="rect">
-            <a:avLst/>
-          </a:prstGeom>
-        </p:spPr>
-      </p:pic>
-    </p:spTree>
-    <p:extLst>
-      <p:ext uri="{BB962C8B-B14F-4D97-AF65-F5344CB8AC3E}">
-        <p14:creationId xmlns:p14="http://schemas.microsoft.com/office/powerpoint/2010/main" val="937068611"/>
-      </p:ext>
-    </p:extLst>
   </p:cSld>
   <p:clrMapOvr>
     <a:masterClrMapping/>

</xml_diff>